<commit_message>
ajustes en presentacion, push final
</commit_message>
<xml_diff>
--- a/presentation/Apartment_Rent_Predictor.pptx
+++ b/presentation/Apartment_Rent_Predictor.pptx
@@ -2921,7 +2921,7 @@
           </a:prstGeom>
           <a:extLst>
             <a:ext uri="{C572A759-6A51-4108-AA02-DFA0A04FC94B}">
-              <ma14:wrappingTextBoxFlag xmlns:ma14="http://schemas.microsoft.com/office/mac/drawingml/2011/main" xmlns="" val="0"/>
+              <ma14:wrappingTextBoxFlag xmlns="" xmlns:ma14="http://schemas.microsoft.com/office/mac/drawingml/2011/main" val="0"/>
             </a:ext>
           </a:extLst>
         </p:spPr>
@@ -3070,7 +3070,7 @@
           </a:prstGeom>
           <a:extLst>
             <a:ext uri="{C572A759-6A51-4108-AA02-DFA0A04FC94B}">
-              <ma14:wrappingTextBoxFlag xmlns:ma14="http://schemas.microsoft.com/office/mac/drawingml/2011/main" xmlns="" val="0"/>
+              <ma14:wrappingTextBoxFlag xmlns="" xmlns:ma14="http://schemas.microsoft.com/office/mac/drawingml/2011/main" val="0"/>
             </a:ext>
           </a:extLst>
         </p:spPr>
@@ -3909,7 +3909,7 @@
           </a:prstGeom>
           <a:extLst>
             <a:ext uri="{C572A759-6A51-4108-AA02-DFA0A04FC94B}">
-              <ma14:wrappingTextBoxFlag xmlns:ma14="http://schemas.microsoft.com/office/mac/drawingml/2011/main" xmlns="" val="0"/>
+              <ma14:wrappingTextBoxFlag xmlns="" xmlns:ma14="http://schemas.microsoft.com/office/mac/drawingml/2011/main" val="0"/>
             </a:ext>
           </a:extLst>
         </p:spPr>
@@ -4352,7 +4352,7 @@
           </a:prstGeom>
           <a:extLst>
             <a:ext uri="{C572A759-6A51-4108-AA02-DFA0A04FC94B}">
-              <ma14:wrappingTextBoxFlag xmlns:ma14="http://schemas.microsoft.com/office/mac/drawingml/2011/main" xmlns="" val="0"/>
+              <ma14:wrappingTextBoxFlag xmlns="" xmlns:ma14="http://schemas.microsoft.com/office/mac/drawingml/2011/main" val="0"/>
             </a:ext>
           </a:extLst>
         </p:spPr>
@@ -6352,7 +6352,7 @@
           </a:prstGeom>
           <a:extLst>
             <a:ext uri="{C572A759-6A51-4108-AA02-DFA0A04FC94B}">
-              <ma14:wrappingTextBoxFlag xmlns:ma14="http://schemas.microsoft.com/office/mac/drawingml/2011/main" xmlns="" val="0"/>
+              <ma14:wrappingTextBoxFlag xmlns="" xmlns:ma14="http://schemas.microsoft.com/office/mac/drawingml/2011/main" val="0"/>
             </a:ext>
           </a:extLst>
         </p:spPr>
@@ -6998,7 +6998,7 @@
         </p:nvSpPr>
         <p:spPr>
           <a:xfrm>
-            <a:off x="5394960" y="2926080"/>
+            <a:off x="5440680" y="2935224"/>
             <a:ext cx="3063240" cy="384048"/>
           </a:xfrm>
           <a:prstGeom prst="rect">
@@ -7015,12 +7015,12 @@
               <a:buNone/>
             </a:pPr>
             <a:r>
-              <a:rPr lang="en-US" sz="1600" b="1" dirty="0">
+              <a:rPr lang="en-US" sz="1600" b="1" dirty="0" err="1">
                 <a:solidFill>
                   <a:schemeClr val="tx2"/>
                 </a:solidFill>
               </a:rPr>
-              <a:t>Ajuste no óptimo</a:t>
+              <a:t>Ajuste</a:t>
             </a:r>
             <a:endParaRPr lang="en-US" sz="1600" dirty="0"/>
           </a:p>
@@ -7056,7 +7056,23 @@
                   <a:schemeClr val="accent4"/>
                 </a:solidFill>
               </a:rPr>
-              <a:t>Grid y Random Search dan el mejor de lo probado, no el óptimo.</a:t>
+              <a:t>Grid y Random Search dan el mejor de lo </a:t>
+            </a:r>
+            <a:r>
+              <a:rPr lang="en-US" sz="1300" dirty="0" err="1">
+                <a:solidFill>
+                  <a:schemeClr val="accent4"/>
+                </a:solidFill>
+              </a:rPr>
+              <a:t>probado</a:t>
+            </a:r>
+            <a:r>
+              <a:rPr lang="en-US" sz="1300" dirty="0">
+                <a:solidFill>
+                  <a:schemeClr val="accent4"/>
+                </a:solidFill>
+              </a:rPr>
+              <a:t>.</a:t>
             </a:r>
             <a:endParaRPr lang="en-US" sz="1300" dirty="0"/>
           </a:p>
@@ -7082,7 +7098,7 @@
           </a:prstGeom>
           <a:extLst>
             <a:ext uri="{C572A759-6A51-4108-AA02-DFA0A04FC94B}">
-              <ma14:wrappingTextBoxFlag xmlns:ma14="http://schemas.microsoft.com/office/mac/drawingml/2011/main" xmlns="" val="0"/>
+              <ma14:wrappingTextBoxFlag xmlns="" xmlns:ma14="http://schemas.microsoft.com/office/mac/drawingml/2011/main" val="0"/>
             </a:ext>
           </a:extLst>
         </p:spPr>
@@ -7488,7 +7504,7 @@
           </a:prstGeom>
           <a:extLst>
             <a:ext uri="{C572A759-6A51-4108-AA02-DFA0A04FC94B}">
-              <ma14:wrappingTextBoxFlag xmlns:ma14="http://schemas.microsoft.com/office/mac/drawingml/2011/main" xmlns="" val="0"/>
+              <ma14:wrappingTextBoxFlag xmlns="" xmlns:ma14="http://schemas.microsoft.com/office/mac/drawingml/2011/main" val="0"/>
             </a:ext>
           </a:extLst>
         </p:spPr>
@@ -8875,7 +8891,7 @@
           </a:prstGeom>
           <a:extLst>
             <a:ext uri="{C572A759-6A51-4108-AA02-DFA0A04FC94B}">
-              <ma14:wrappingTextBoxFlag xmlns:ma14="http://schemas.microsoft.com/office/mac/drawingml/2011/main" xmlns="" val="0"/>
+              <ma14:wrappingTextBoxFlag xmlns="" xmlns:ma14="http://schemas.microsoft.com/office/mac/drawingml/2011/main" val="0"/>
             </a:ext>
           </a:extLst>
         </p:spPr>
@@ -9460,7 +9476,7 @@
                   <a:schemeClr val="tx2"/>
                 </a:solidFill>
               </a:rPr>
-              <a:t>Los huecos también son información</a:t>
+              <a:t>Los null también son información</a:t>
             </a:r>
             <a:endParaRPr lang="en-US" sz="1400" dirty="0"/>
           </a:p>
@@ -9777,7 +9793,7 @@
           </a:prstGeom>
           <a:extLst>
             <a:ext uri="{C572A759-6A51-4108-AA02-DFA0A04FC94B}">
-              <ma14:wrappingTextBoxFlag xmlns:ma14="http://schemas.microsoft.com/office/mac/drawingml/2011/main" xmlns="" val="0"/>
+              <ma14:wrappingTextBoxFlag xmlns="" xmlns:ma14="http://schemas.microsoft.com/office/mac/drawingml/2011/main" val="0"/>
             </a:ext>
           </a:extLst>
         </p:spPr>
@@ -10331,7 +10347,7 @@
           </a:prstGeom>
           <a:extLst>
             <a:ext uri="{C572A759-6A51-4108-AA02-DFA0A04FC94B}">
-              <ma14:wrappingTextBoxFlag xmlns:ma14="http://schemas.microsoft.com/office/mac/drawingml/2011/main" xmlns="" val="0"/>
+              <ma14:wrappingTextBoxFlag xmlns="" xmlns:ma14="http://schemas.microsoft.com/office/mac/drawingml/2011/main" val="0"/>
             </a:ext>
           </a:extLst>
         </p:spPr>
@@ -11806,7 +11822,7 @@
           </a:prstGeom>
           <a:extLst>
             <a:ext uri="{C572A759-6A51-4108-AA02-DFA0A04FC94B}">
-              <ma14:wrappingTextBoxFlag xmlns:ma14="http://schemas.microsoft.com/office/mac/drawingml/2011/main" xmlns="" val="0"/>
+              <ma14:wrappingTextBoxFlag xmlns="" xmlns:ma14="http://schemas.microsoft.com/office/mac/drawingml/2011/main" val="0"/>
             </a:ext>
           </a:extLst>
         </p:spPr>
@@ -11905,21 +11921,21 @@
           <p:nvPr>
             <p:extLst>
               <p:ext uri="{D42A27DB-BD31-4B8C-83A1-F6EECF244321}">
-                <p14:modId xmlns:p14="http://schemas.microsoft.com/office/powerpoint/2010/main" val="1579011935"/>
+                <p14:modId xmlns:p14="http://schemas.microsoft.com/office/powerpoint/2010/main" val="2980984745"/>
               </p:ext>
             </p:extLst>
           </p:nvPr>
         </p:nvGraphicFramePr>
         <p:xfrm>
-          <a:off x="457200" y="1005840"/>
-          <a:ext cx="8229600" cy="2371344"/>
+          <a:off x="468351" y="1005840"/>
+          <a:ext cx="8218449" cy="2371344"/>
         </p:xfrm>
         <a:graphic>
           <a:graphicData uri="http://schemas.openxmlformats.org/drawingml/2006/table">
             <a:tbl>
               <a:tblPr/>
               <a:tblGrid>
-                <a:gridCol w="1463040">
+                <a:gridCol w="1451889">
                   <a:extLst>
                     <a:ext uri="{9D8B030D-6E8A-4147-A177-3AD203B41FA5}">
                       <a16:colId xmlns:a16="http://schemas.microsoft.com/office/drawing/2014/main" val="20000"/>
@@ -16066,7 +16082,7 @@
           </a:prstGeom>
           <a:extLst>
             <a:ext uri="{C572A759-6A51-4108-AA02-DFA0A04FC94B}">
-              <ma14:wrappingTextBoxFlag xmlns:ma14="http://schemas.microsoft.com/office/mac/drawingml/2011/main" xmlns="" val="0"/>
+              <ma14:wrappingTextBoxFlag xmlns="" xmlns:ma14="http://schemas.microsoft.com/office/mac/drawingml/2011/main" val="0"/>
             </a:ext>
           </a:extLst>
         </p:spPr>
@@ -19085,7 +19101,7 @@
           </a:prstGeom>
           <a:extLst>
             <a:ext uri="{C572A759-6A51-4108-AA02-DFA0A04FC94B}">
-              <ma14:wrappingTextBoxFlag xmlns:ma14="http://schemas.microsoft.com/office/mac/drawingml/2011/main" xmlns="" val="0"/>
+              <ma14:wrappingTextBoxFlag xmlns="" xmlns:ma14="http://schemas.microsoft.com/office/mac/drawingml/2011/main" val="0"/>
             </a:ext>
           </a:extLst>
         </p:spPr>
@@ -20955,7 +20971,7 @@
           </a:prstGeom>
           <a:extLst>
             <a:ext uri="{C572A759-6A51-4108-AA02-DFA0A04FC94B}">
-              <ma14:wrappingTextBoxFlag xmlns:ma14="http://schemas.microsoft.com/office/mac/drawingml/2011/main" xmlns="" val="0"/>
+              <ma14:wrappingTextBoxFlag xmlns="" xmlns:ma14="http://schemas.microsoft.com/office/mac/drawingml/2011/main" val="0"/>
             </a:ext>
           </a:extLst>
         </p:spPr>
@@ -21333,7 +21349,7 @@
           </a:prstGeom>
           <a:extLst>
             <a:ext uri="{C572A759-6A51-4108-AA02-DFA0A04FC94B}">
-              <ma14:wrappingTextBoxFlag xmlns:ma14="http://schemas.microsoft.com/office/mac/drawingml/2011/main" xmlns="" val="0"/>
+              <ma14:wrappingTextBoxFlag xmlns="" xmlns:ma14="http://schemas.microsoft.com/office/mac/drawingml/2011/main" val="0"/>
             </a:ext>
           </a:extLst>
         </p:spPr>

</xml_diff>